<commit_message>
docs: live URLs in README, demo script and presentation; ignore Vercel local files
</commit_message>
<xml_diff>
--- a/docs/presentation/AlerteAgri-presentation.pptx
+++ b/docs/presentation/AlerteAgri-presentation.pptx
@@ -1013,7 +1013,7 @@
           <a:lstStyle/>
           <a:p>
             <a:r>
-              <a:t>Enchaîner sur la démonstration (docs/DEMO.md). Remplacer l’adresse Vercel par l’adresse finale avant l’entretien.</a:t>
+              <a:t>Enchaîner sur la démonstration (docs/DEMO.md). Adresse en ligne : https://alerteagri.vercel.app</a:t>
             </a:r>
           </a:p>
         </p:txBody>
@@ -6944,7 +6944,7 @@
                 </a:solidFill>
                 <a:latin typeface="Calibri"/>
               </a:rPr>
-              <a:t>alerteagri (Vercel)</a:t>
+              <a:t>alerteagri.vercel.app</a:t>
             </a:r>
           </a:p>
         </p:txBody>

</xml_diff>

<commit_message>
docs: refresh the presentation with the charter palette and current figures
313 automated tests, zero accessibility violation, continuous
integration, Fon and Yoruba synthetic voices stated as such, and
screenshots from production.
</commit_message>
<xml_diff>
--- a/docs/presentation/AlerteAgri-presentation.pptx
+++ b/docs/presentation/AlerteAgri-presentation.pptx
@@ -143,7 +143,7 @@
           </c:tx>
           <c:spPr>
             <a:solidFill>
-              <a:srgbClr val="14532D"/>
+              <a:srgbClr val="007A4A"/>
             </a:solidFill>
           </c:spPr>
           <c:cat>
@@ -4575,7 +4575,7 @@
     <p:bg>
       <p:bgPr>
         <a:solidFill>
-          <a:srgbClr val="14532D"/>
+          <a:srgbClr val="007A4A"/>
         </a:solidFill>
         <a:effectLst/>
       </p:bgPr>
@@ -4613,7 +4613,7 @@
             <a:r>
               <a:rPr sz="1400" b="1" i="0">
                 <a:solidFill>
-                  <a:srgbClr val="E3F2E8"/>
+                  <a:srgbClr val="E0F3E9"/>
                 </a:solidFill>
                 <a:latin typeface="Calibri"/>
               </a:rPr>
@@ -4683,7 +4683,7 @@
             <a:r>
               <a:rPr sz="3200" b="0" i="0">
                 <a:solidFill>
-                  <a:srgbClr val="E3F2E8"/>
+                  <a:srgbClr val="E0F3E9"/>
                 </a:solidFill>
                 <a:latin typeface="Cambria"/>
               </a:rPr>
@@ -4753,7 +4753,7 @@
             <a:r>
               <a:rPr sz="1300" b="0" i="0">
                 <a:solidFill>
-                  <a:srgbClr val="E3F2E8"/>
+                  <a:srgbClr val="E0F3E9"/>
                 </a:solidFill>
                 <a:latin typeface="Calibri"/>
               </a:rPr>
@@ -4791,6 +4791,182 @@
           </a:ln>
         </p:spPr>
       </p:pic>
+      <p:sp>
+        <p:nvSpPr>
+          <p:cNvPr id="8" name="Rectangle 7"/>
+          <p:cNvSpPr/>
+          <p:nvPr/>
+        </p:nvSpPr>
+        <p:spPr>
+          <a:xfrm>
+            <a:off x="0" y="6711696"/>
+            <a:ext cx="12191695" cy="36576"/>
+          </a:xfrm>
+          <a:prstGeom prst="rect">
+            <a:avLst/>
+          </a:prstGeom>
+          <a:solidFill>
+            <a:srgbClr val="FFFFFF"/>
+          </a:solidFill>
+          <a:ln>
+            <a:noFill/>
+          </a:ln>
+          <a:effectLst/>
+        </p:spPr>
+        <p:style>
+          <a:lnRef idx="1">
+            <a:schemeClr val="accent1"/>
+          </a:lnRef>
+          <a:fillRef idx="3">
+            <a:schemeClr val="accent1"/>
+          </a:fillRef>
+          <a:effectRef idx="2">
+            <a:schemeClr val="accent1"/>
+          </a:effectRef>
+          <a:fontRef idx="minor">
+            <a:schemeClr val="lt1"/>
+          </a:fontRef>
+        </p:style>
+        <p:txBody>
+          <a:bodyPr rtlCol="0" anchor="ctr"/>
+          <a:lstStyle/>
+          <a:p>
+            <a:pPr algn="ctr"/>
+          </a:p>
+        </p:txBody>
+      </p:sp>
+      <p:sp>
+        <p:nvSpPr>
+          <p:cNvPr id="9" name="Rectangle 8"/>
+          <p:cNvSpPr/>
+          <p:nvPr/>
+        </p:nvSpPr>
+        <p:spPr>
+          <a:xfrm>
+            <a:off x="0" y="6748272"/>
+            <a:ext cx="4073042" cy="109728"/>
+          </a:xfrm>
+          <a:prstGeom prst="rect">
+            <a:avLst/>
+          </a:prstGeom>
+          <a:solidFill>
+            <a:srgbClr val="008751"/>
+          </a:solidFill>
+          <a:ln>
+            <a:noFill/>
+          </a:ln>
+          <a:effectLst/>
+        </p:spPr>
+        <p:style>
+          <a:lnRef idx="1">
+            <a:schemeClr val="accent1"/>
+          </a:lnRef>
+          <a:fillRef idx="3">
+            <a:schemeClr val="accent1"/>
+          </a:fillRef>
+          <a:effectRef idx="2">
+            <a:schemeClr val="accent1"/>
+          </a:effectRef>
+          <a:fontRef idx="minor">
+            <a:schemeClr val="lt1"/>
+          </a:fontRef>
+        </p:style>
+        <p:txBody>
+          <a:bodyPr rtlCol="0" anchor="ctr"/>
+          <a:lstStyle/>
+          <a:p>
+            <a:pPr algn="ctr"/>
+          </a:p>
+        </p:txBody>
+      </p:sp>
+      <p:sp>
+        <p:nvSpPr>
+          <p:cNvPr id="10" name="Rectangle 9"/>
+          <p:cNvSpPr/>
+          <p:nvPr/>
+        </p:nvSpPr>
+        <p:spPr>
+          <a:xfrm>
+            <a:off x="4063898" y="6748272"/>
+            <a:ext cx="4073042" cy="109728"/>
+          </a:xfrm>
+          <a:prstGeom prst="rect">
+            <a:avLst/>
+          </a:prstGeom>
+          <a:solidFill>
+            <a:srgbClr val="FCD116"/>
+          </a:solidFill>
+          <a:ln>
+            <a:noFill/>
+          </a:ln>
+          <a:effectLst/>
+        </p:spPr>
+        <p:style>
+          <a:lnRef idx="1">
+            <a:schemeClr val="accent1"/>
+          </a:lnRef>
+          <a:fillRef idx="3">
+            <a:schemeClr val="accent1"/>
+          </a:fillRef>
+          <a:effectRef idx="2">
+            <a:schemeClr val="accent1"/>
+          </a:effectRef>
+          <a:fontRef idx="minor">
+            <a:schemeClr val="lt1"/>
+          </a:fontRef>
+        </p:style>
+        <p:txBody>
+          <a:bodyPr rtlCol="0" anchor="ctr"/>
+          <a:lstStyle/>
+          <a:p>
+            <a:pPr algn="ctr"/>
+          </a:p>
+        </p:txBody>
+      </p:sp>
+      <p:sp>
+        <p:nvSpPr>
+          <p:cNvPr id="11" name="Rectangle 10"/>
+          <p:cNvSpPr/>
+          <p:nvPr/>
+        </p:nvSpPr>
+        <p:spPr>
+          <a:xfrm>
+            <a:off x="8127796" y="6748272"/>
+            <a:ext cx="4073042" cy="109728"/>
+          </a:xfrm>
+          <a:prstGeom prst="rect">
+            <a:avLst/>
+          </a:prstGeom>
+          <a:solidFill>
+            <a:srgbClr val="E8112D"/>
+          </a:solidFill>
+          <a:ln>
+            <a:noFill/>
+          </a:ln>
+          <a:effectLst/>
+        </p:spPr>
+        <p:style>
+          <a:lnRef idx="1">
+            <a:schemeClr val="accent1"/>
+          </a:lnRef>
+          <a:fillRef idx="3">
+            <a:schemeClr val="accent1"/>
+          </a:fillRef>
+          <a:effectRef idx="2">
+            <a:schemeClr val="accent1"/>
+          </a:effectRef>
+          <a:fontRef idx="minor">
+            <a:schemeClr val="lt1"/>
+          </a:fontRef>
+        </p:style>
+        <p:txBody>
+          <a:bodyPr rtlCol="0" anchor="ctr"/>
+          <a:lstStyle/>
+          <a:p>
+            <a:pPr algn="ctr"/>
+          </a:p>
+        </p:txBody>
+      </p:sp>
     </p:spTree>
   </p:cSld>
   <p:clrMapOvr>
@@ -4931,7 +5107,7 @@
             <a:avLst/>
           </a:prstGeom>
           <a:solidFill>
-            <a:srgbClr val="14532D"/>
+            <a:srgbClr val="007A4A"/>
           </a:solidFill>
           <a:ln>
             <a:noFill/>
@@ -5054,7 +5230,7 @@
             <a:avLst/>
           </a:prstGeom>
           <a:solidFill>
-            <a:srgbClr val="14532D"/>
+            <a:srgbClr val="007A4A"/>
           </a:solidFill>
           <a:ln>
             <a:noFill/>
@@ -5177,7 +5353,7 @@
             <a:avLst/>
           </a:prstGeom>
           <a:solidFill>
-            <a:srgbClr val="14532D"/>
+            <a:srgbClr val="007A4A"/>
           </a:solidFill>
           <a:ln>
             <a:noFill/>
@@ -5300,7 +5476,7 @@
             <a:avLst/>
           </a:prstGeom>
           <a:solidFill>
-            <a:srgbClr val="14532D"/>
+            <a:srgbClr val="007A4A"/>
           </a:solidFill>
           <a:ln>
             <a:noFill/>
@@ -5530,11 +5706,11 @@
             <a:r>
               <a:rPr sz="4800" b="1" i="0">
                 <a:solidFill>
-                  <a:srgbClr val="14532D"/>
+                  <a:srgbClr val="007A4A"/>
                 </a:solidFill>
                 <a:latin typeface="Cambria"/>
               </a:rPr>
-              <a:t>120</a:t>
+              <a:t>313</a:t>
             </a:r>
           </a:p>
         </p:txBody>
@@ -5604,7 +5780,7 @@
                 </a:solidFill>
                 <a:latin typeface="Calibri"/>
               </a:rPr>
-              <a:t>53 sur une vraie base PostgreSQL</a:t>
+              <a:t>82 métier, 59 API sur PostgreSQL, 172 dans le navigateur</a:t>
             </a:r>
           </a:p>
         </p:txBody>
@@ -5635,7 +5811,7 @@
             <a:r>
               <a:rPr sz="4800" b="1" i="0">
                 <a:solidFill>
-                  <a:srgbClr val="14532D"/>
+                  <a:srgbClr val="007A4A"/>
                 </a:solidFill>
                 <a:latin typeface="Cambria"/>
               </a:rPr>
@@ -5740,11 +5916,11 @@
             <a:r>
               <a:rPr sz="4800" b="1" i="0">
                 <a:solidFill>
-                  <a:srgbClr val="14532D"/>
+                  <a:srgbClr val="007A4A"/>
                 </a:solidFill>
                 <a:latin typeface="Cambria"/>
               </a:rPr>
-              <a:t>13 / 13</a:t>
+              <a:t>0</a:t>
             </a:r>
           </a:p>
         </p:txBody>
@@ -5779,7 +5955,7 @@
                 </a:solidFill>
                 <a:latin typeface="Calibri"/>
               </a:rPr>
-              <a:t>failles réintroduites</a:t>
+              <a:t>violation d’accessibilité</a:t>
             </a:r>
           </a:p>
         </p:txBody>
@@ -5814,7 +5990,7 @@
                 </a:solidFill>
                 <a:latin typeface="Calibri"/>
               </a:rPr>
-              <a:t>toutes détectées par les tests</a:t>
+              <a:t>WCAG 2.1 AA, 18 écrans, mobile et ordinateur, clair et sombre</a:t>
             </a:r>
           </a:p>
         </p:txBody>
@@ -5845,7 +6021,7 @@
             <a:r>
               <a:rPr sz="4800" b="1" i="0">
                 <a:solidFill>
-                  <a:srgbClr val="14532D"/>
+                  <a:srgbClr val="007A4A"/>
                 </a:solidFill>
                 <a:latin typeface="Cambria"/>
               </a:rPr>
@@ -5933,7 +6109,7 @@
         <p:spPr>
           <a:xfrm>
             <a:off x="548640" y="4114800"/>
-            <a:ext cx="11064240" cy="2011680"/>
+            <a:ext cx="11064240" cy="1600200"/>
           </a:xfrm>
           <a:prstGeom prst="roundRect">
             <a:avLst>
@@ -5941,7 +6117,7 @@
             </a:avLst>
           </a:prstGeom>
           <a:solidFill>
-            <a:srgbClr val="E3F2E8"/>
+            <a:srgbClr val="E0F3E9"/>
           </a:solidFill>
           <a:ln>
             <a:noFill/>
@@ -5979,7 +6155,7 @@
         <p:spPr>
           <a:xfrm>
             <a:off x="868680" y="4343400"/>
-            <a:ext cx="10424160" cy="1645920"/>
+            <a:ext cx="10424160" cy="1280160"/>
           </a:xfrm>
           <a:prstGeom prst="rect">
             <a:avLst/>
@@ -6054,7 +6230,7 @@
                 </a:solidFill>
                 <a:latin typeface="Calibri"/>
               </a:rPr>
-              <a:t>Failles trouvées et corrigées pendant la livraison : </a:t>
+              <a:t>Intégration continue : </a:t>
             </a:r>
             <a:r>
               <a:rPr sz="1500" b="0" i="0">
@@ -6063,7 +6239,7 @@
                 </a:solidFill>
                 <a:latin typeface="Calibri"/>
               </a:rPr>
-              <a:t>inscription en administrateur, PIN devinable, reçu invalide trop bavard.</a:t>
+              <a:t>chaque modification passe lint, TypeScript strict, tests et audit d’accessibilité avant d’entrer dans le code.</a:t>
             </a:r>
           </a:p>
         </p:txBody>
@@ -6181,7 +6357,7 @@
             </a:avLst>
           </a:prstGeom>
           <a:solidFill>
-            <a:srgbClr val="E3F2E8"/>
+            <a:srgbClr val="E0F3E9"/>
           </a:solidFill>
           <a:ln>
             <a:noFill/>
@@ -6368,7 +6544,7 @@
             </a:avLst>
           </a:prstGeom>
           <a:solidFill>
-            <a:srgbClr val="14532D"/>
+            <a:srgbClr val="007A4A"/>
           </a:solidFill>
           <a:ln>
             <a:noFill/>
@@ -6423,7 +6599,7 @@
             <a:r>
               <a:rPr sz="1400" b="1" i="0">
                 <a:solidFill>
-                  <a:srgbClr val="E3F2E8"/>
+                  <a:srgbClr val="E0F3E9"/>
                 </a:solidFill>
                 <a:latin typeface="Calibri"/>
               </a:rPr>
@@ -6555,7 +6731,7 @@
             </a:avLst>
           </a:prstGeom>
           <a:solidFill>
-            <a:srgbClr val="E3F2E8"/>
+            <a:srgbClr val="E0F3E9"/>
           </a:solidFill>
           <a:ln>
             <a:noFill/>
@@ -6774,7 +6950,7 @@
     <p:bg>
       <p:bgPr>
         <a:solidFill>
-          <a:srgbClr val="14532D"/>
+          <a:srgbClr val="007A4A"/>
         </a:solidFill>
         <a:effectLst/>
       </p:bgPr>
@@ -6847,7 +7023,7 @@
             <a:r>
               <a:rPr sz="2200" b="0" i="0">
                 <a:solidFill>
-                  <a:srgbClr val="E3F2E8"/>
+                  <a:srgbClr val="E0F3E9"/>
                 </a:solidFill>
                 <a:latin typeface="Calibri"/>
               </a:rPr>
@@ -6873,7 +7049,7 @@
             </a:avLst>
           </a:prstGeom>
           <a:solidFill>
-            <a:srgbClr val="0E3B20"/>
+            <a:srgbClr val="005C38"/>
           </a:solidFill>
           <a:ln>
             <a:noFill/>
@@ -6928,7 +7104,7 @@
             <a:r>
               <a:rPr sz="1300" b="1" i="0">
                 <a:solidFill>
-                  <a:srgbClr val="E3F2E8"/>
+                  <a:srgbClr val="E0F3E9"/>
                 </a:solidFill>
                 <a:latin typeface="Calibri"/>
               </a:rPr>
@@ -6966,7 +7142,7 @@
             </a:avLst>
           </a:prstGeom>
           <a:solidFill>
-            <a:srgbClr val="0E3B20"/>
+            <a:srgbClr val="005C38"/>
           </a:solidFill>
           <a:ln>
             <a:noFill/>
@@ -7021,7 +7197,7 @@
             <a:r>
               <a:rPr sz="1300" b="1" i="0">
                 <a:solidFill>
-                  <a:srgbClr val="E3F2E8"/>
+                  <a:srgbClr val="E0F3E9"/>
                 </a:solidFill>
                 <a:latin typeface="Calibri"/>
               </a:rPr>
@@ -7059,7 +7235,7 @@
             </a:avLst>
           </a:prstGeom>
           <a:solidFill>
-            <a:srgbClr val="0E3B20"/>
+            <a:srgbClr val="005C38"/>
           </a:solidFill>
           <a:ln>
             <a:noFill/>
@@ -7114,7 +7290,7 @@
             <a:r>
               <a:rPr sz="1300" b="1" i="0">
                 <a:solidFill>
-                  <a:srgbClr val="E3F2E8"/>
+                  <a:srgbClr val="E0F3E9"/>
                 </a:solidFill>
                 <a:latin typeface="Calibri"/>
               </a:rPr>
@@ -7161,12 +7337,188 @@
             <a:r>
               <a:rPr sz="1600" b="0" i="0">
                 <a:solidFill>
-                  <a:srgbClr val="E3F2E8"/>
+                  <a:srgbClr val="E0F3E9"/>
                 </a:solidFill>
                 <a:latin typeface="Calibri"/>
               </a:rPr>
               <a:t>Merci. Place aux questions et à la démonstration.</a:t>
             </a:r>
+          </a:p>
+        </p:txBody>
+      </p:sp>
+      <p:sp>
+        <p:nvSpPr>
+          <p:cNvPr id="11" name="Rectangle 10"/>
+          <p:cNvSpPr/>
+          <p:nvPr/>
+        </p:nvSpPr>
+        <p:spPr>
+          <a:xfrm>
+            <a:off x="0" y="6711696"/>
+            <a:ext cx="12191695" cy="36576"/>
+          </a:xfrm>
+          <a:prstGeom prst="rect">
+            <a:avLst/>
+          </a:prstGeom>
+          <a:solidFill>
+            <a:srgbClr val="FFFFFF"/>
+          </a:solidFill>
+          <a:ln>
+            <a:noFill/>
+          </a:ln>
+          <a:effectLst/>
+        </p:spPr>
+        <p:style>
+          <a:lnRef idx="1">
+            <a:schemeClr val="accent1"/>
+          </a:lnRef>
+          <a:fillRef idx="3">
+            <a:schemeClr val="accent1"/>
+          </a:fillRef>
+          <a:effectRef idx="2">
+            <a:schemeClr val="accent1"/>
+          </a:effectRef>
+          <a:fontRef idx="minor">
+            <a:schemeClr val="lt1"/>
+          </a:fontRef>
+        </p:style>
+        <p:txBody>
+          <a:bodyPr rtlCol="0" anchor="ctr"/>
+          <a:lstStyle/>
+          <a:p>
+            <a:pPr algn="ctr"/>
+          </a:p>
+        </p:txBody>
+      </p:sp>
+      <p:sp>
+        <p:nvSpPr>
+          <p:cNvPr id="12" name="Rectangle 11"/>
+          <p:cNvSpPr/>
+          <p:nvPr/>
+        </p:nvSpPr>
+        <p:spPr>
+          <a:xfrm>
+            <a:off x="0" y="6748272"/>
+            <a:ext cx="4073042" cy="109728"/>
+          </a:xfrm>
+          <a:prstGeom prst="rect">
+            <a:avLst/>
+          </a:prstGeom>
+          <a:solidFill>
+            <a:srgbClr val="008751"/>
+          </a:solidFill>
+          <a:ln>
+            <a:noFill/>
+          </a:ln>
+          <a:effectLst/>
+        </p:spPr>
+        <p:style>
+          <a:lnRef idx="1">
+            <a:schemeClr val="accent1"/>
+          </a:lnRef>
+          <a:fillRef idx="3">
+            <a:schemeClr val="accent1"/>
+          </a:fillRef>
+          <a:effectRef idx="2">
+            <a:schemeClr val="accent1"/>
+          </a:effectRef>
+          <a:fontRef idx="minor">
+            <a:schemeClr val="lt1"/>
+          </a:fontRef>
+        </p:style>
+        <p:txBody>
+          <a:bodyPr rtlCol="0" anchor="ctr"/>
+          <a:lstStyle/>
+          <a:p>
+            <a:pPr algn="ctr"/>
+          </a:p>
+        </p:txBody>
+      </p:sp>
+      <p:sp>
+        <p:nvSpPr>
+          <p:cNvPr id="13" name="Rectangle 12"/>
+          <p:cNvSpPr/>
+          <p:nvPr/>
+        </p:nvSpPr>
+        <p:spPr>
+          <a:xfrm>
+            <a:off x="4063898" y="6748272"/>
+            <a:ext cx="4073042" cy="109728"/>
+          </a:xfrm>
+          <a:prstGeom prst="rect">
+            <a:avLst/>
+          </a:prstGeom>
+          <a:solidFill>
+            <a:srgbClr val="FCD116"/>
+          </a:solidFill>
+          <a:ln>
+            <a:noFill/>
+          </a:ln>
+          <a:effectLst/>
+        </p:spPr>
+        <p:style>
+          <a:lnRef idx="1">
+            <a:schemeClr val="accent1"/>
+          </a:lnRef>
+          <a:fillRef idx="3">
+            <a:schemeClr val="accent1"/>
+          </a:fillRef>
+          <a:effectRef idx="2">
+            <a:schemeClr val="accent1"/>
+          </a:effectRef>
+          <a:fontRef idx="minor">
+            <a:schemeClr val="lt1"/>
+          </a:fontRef>
+        </p:style>
+        <p:txBody>
+          <a:bodyPr rtlCol="0" anchor="ctr"/>
+          <a:lstStyle/>
+          <a:p>
+            <a:pPr algn="ctr"/>
+          </a:p>
+        </p:txBody>
+      </p:sp>
+      <p:sp>
+        <p:nvSpPr>
+          <p:cNvPr id="14" name="Rectangle 13"/>
+          <p:cNvSpPr/>
+          <p:nvPr/>
+        </p:nvSpPr>
+        <p:spPr>
+          <a:xfrm>
+            <a:off x="8127796" y="6748272"/>
+            <a:ext cx="4073042" cy="109728"/>
+          </a:xfrm>
+          <a:prstGeom prst="rect">
+            <a:avLst/>
+          </a:prstGeom>
+          <a:solidFill>
+            <a:srgbClr val="E8112D"/>
+          </a:solidFill>
+          <a:ln>
+            <a:noFill/>
+          </a:ln>
+          <a:effectLst/>
+        </p:spPr>
+        <p:style>
+          <a:lnRef idx="1">
+            <a:schemeClr val="accent1"/>
+          </a:lnRef>
+          <a:fillRef idx="3">
+            <a:schemeClr val="accent1"/>
+          </a:fillRef>
+          <a:effectRef idx="2">
+            <a:schemeClr val="accent1"/>
+          </a:effectRef>
+          <a:fontRef idx="minor">
+            <a:schemeClr val="lt1"/>
+          </a:fontRef>
+        </p:style>
+        <p:txBody>
+          <a:bodyPr rtlCol="0" anchor="ctr"/>
+          <a:lstStyle/>
+          <a:p>
+            <a:pPr algn="ctr"/>
           </a:p>
         </p:txBody>
       </p:sp>
@@ -7283,7 +7635,7 @@
             </a:avLst>
           </a:prstGeom>
           <a:solidFill>
-            <a:srgbClr val="E3F2E8"/>
+            <a:srgbClr val="E0F3E9"/>
           </a:solidFill>
           <a:ln>
             <a:noFill/>
@@ -7338,7 +7690,7 @@
             <a:r>
               <a:rPr sz="3600" b="1" i="0">
                 <a:solidFill>
-                  <a:srgbClr val="14532D"/>
+                  <a:srgbClr val="007A4A"/>
                 </a:solidFill>
                 <a:latin typeface="Cambria"/>
               </a:rPr>
@@ -7434,7 +7786,7 @@
             </a:avLst>
           </a:prstGeom>
           <a:solidFill>
-            <a:srgbClr val="E3F2E8"/>
+            <a:srgbClr val="E0F3E9"/>
           </a:solidFill>
           <a:ln>
             <a:noFill/>
@@ -7489,7 +7841,7 @@
             <a:r>
               <a:rPr sz="3600" b="1" i="0">
                 <a:solidFill>
-                  <a:srgbClr val="14532D"/>
+                  <a:srgbClr val="007A4A"/>
                 </a:solidFill>
                 <a:latin typeface="Cambria"/>
               </a:rPr>
@@ -8060,7 +8412,7 @@
             <a:avLst/>
           </a:prstGeom>
           <a:solidFill>
-            <a:srgbClr val="14532D"/>
+            <a:srgbClr val="007A4A"/>
           </a:solidFill>
           <a:ln>
             <a:noFill/>
@@ -8183,7 +8535,7 @@
             <a:avLst/>
           </a:prstGeom>
           <a:solidFill>
-            <a:srgbClr val="14532D"/>
+            <a:srgbClr val="007A4A"/>
           </a:solidFill>
           <a:ln>
             <a:noFill/>
@@ -8306,7 +8658,7 @@
             <a:avLst/>
           </a:prstGeom>
           <a:solidFill>
-            <a:srgbClr val="14532D"/>
+            <a:srgbClr val="007A4A"/>
           </a:solidFill>
           <a:ln>
             <a:noFill/>
@@ -8429,7 +8781,7 @@
             <a:avLst/>
           </a:prstGeom>
           <a:solidFill>
-            <a:srgbClr val="14532D"/>
+            <a:srgbClr val="007A4A"/>
           </a:solidFill>
           <a:ln>
             <a:noFill/>
@@ -8615,7 +8967,7 @@
     <p:bg>
       <p:bgPr>
         <a:solidFill>
-          <a:srgbClr val="14532D"/>
+          <a:srgbClr val="007A4A"/>
         </a:solidFill>
         <a:effectLst/>
       </p:bgPr>
@@ -8688,7 +9040,7 @@
             <a:r>
               <a:rPr sz="1600" b="0" i="0">
                 <a:solidFill>
-                  <a:srgbClr val="E3F2E8"/>
+                  <a:srgbClr val="E0F3E9"/>
                 </a:solidFill>
                 <a:latin typeface="Calibri"/>
               </a:rPr>
@@ -8769,7 +9121,7 @@
             <a:r>
               <a:rPr sz="2400" b="1" i="0">
                 <a:solidFill>
-                  <a:srgbClr val="14532D"/>
+                  <a:srgbClr val="007A4A"/>
                 </a:solidFill>
                 <a:latin typeface="Cambria"/>
               </a:rPr>
@@ -8807,7 +9159,7 @@
             </a:avLst>
           </a:prstGeom>
           <a:solidFill>
-            <a:srgbClr val="0E3B20"/>
+            <a:srgbClr val="005C38"/>
           </a:solidFill>
           <a:ln>
             <a:noFill/>
@@ -8874,7 +9226,7 @@
             <a:r>
               <a:rPr sz="1200" b="0" i="0">
                 <a:solidFill>
-                  <a:srgbClr val="E3F2E8"/>
+                  <a:srgbClr val="E0F3E9"/>
                 </a:solidFill>
                 <a:latin typeface="Calibri"/>
               </a:rPr>
@@ -8899,7 +9251,7 @@
           </a:prstGeom>
           <a:ln w="15875">
             <a:solidFill>
-              <a:srgbClr val="E3F2E8"/>
+              <a:srgbClr val="E0F3E9"/>
             </a:solidFill>
           </a:ln>
         </p:spPr>
@@ -8935,7 +9287,7 @@
             </a:avLst>
           </a:prstGeom>
           <a:solidFill>
-            <a:srgbClr val="0E3B20"/>
+            <a:srgbClr val="005C38"/>
           </a:solidFill>
           <a:ln>
             <a:noFill/>
@@ -9002,7 +9354,7 @@
             <a:r>
               <a:rPr sz="1200" b="0" i="0">
                 <a:solidFill>
-                  <a:srgbClr val="E3F2E8"/>
+                  <a:srgbClr val="E0F3E9"/>
                 </a:solidFill>
                 <a:latin typeface="Calibri"/>
               </a:rPr>
@@ -9027,7 +9379,7 @@
           </a:prstGeom>
           <a:ln w="15875">
             <a:solidFill>
-              <a:srgbClr val="E3F2E8"/>
+              <a:srgbClr val="E0F3E9"/>
             </a:solidFill>
           </a:ln>
         </p:spPr>
@@ -9063,7 +9415,7 @@
             </a:avLst>
           </a:prstGeom>
           <a:solidFill>
-            <a:srgbClr val="0E3B20"/>
+            <a:srgbClr val="005C38"/>
           </a:solidFill>
           <a:ln>
             <a:noFill/>
@@ -9130,7 +9482,7 @@
             <a:r>
               <a:rPr sz="1200" b="0" i="0">
                 <a:solidFill>
-                  <a:srgbClr val="E3F2E8"/>
+                  <a:srgbClr val="E0F3E9"/>
                 </a:solidFill>
                 <a:latin typeface="Calibri"/>
               </a:rPr>
@@ -9155,7 +9507,7 @@
           </a:prstGeom>
           <a:ln w="15875">
             <a:solidFill>
-              <a:srgbClr val="E3F2E8"/>
+              <a:srgbClr val="E0F3E9"/>
             </a:solidFill>
           </a:ln>
         </p:spPr>
@@ -9191,7 +9543,7 @@
             </a:avLst>
           </a:prstGeom>
           <a:solidFill>
-            <a:srgbClr val="0E3B20"/>
+            <a:srgbClr val="005C38"/>
           </a:solidFill>
           <a:ln>
             <a:noFill/>
@@ -9258,7 +9610,7 @@
             <a:r>
               <a:rPr sz="1200" b="0" i="0">
                 <a:solidFill>
-                  <a:srgbClr val="E3F2E8"/>
+                  <a:srgbClr val="E0F3E9"/>
                 </a:solidFill>
                 <a:latin typeface="Calibri"/>
               </a:rPr>
@@ -9283,7 +9635,7 @@
           </a:prstGeom>
           <a:ln w="15875">
             <a:solidFill>
-              <a:srgbClr val="E3F2E8"/>
+              <a:srgbClr val="E0F3E9"/>
             </a:solidFill>
           </a:ln>
         </p:spPr>
@@ -9319,7 +9671,7 @@
             </a:avLst>
           </a:prstGeom>
           <a:solidFill>
-            <a:srgbClr val="0E3B20"/>
+            <a:srgbClr val="005C38"/>
           </a:solidFill>
           <a:ln>
             <a:noFill/>
@@ -9386,7 +9738,7 @@
             <a:r>
               <a:rPr sz="1200" b="0" i="0">
                 <a:solidFill>
-                  <a:srgbClr val="E3F2E8"/>
+                  <a:srgbClr val="E0F3E9"/>
                 </a:solidFill>
                 <a:latin typeface="Calibri"/>
               </a:rPr>
@@ -9411,7 +9763,7 @@
           </a:prstGeom>
           <a:ln w="15875">
             <a:solidFill>
-              <a:srgbClr val="E3F2E8"/>
+              <a:srgbClr val="E0F3E9"/>
             </a:solidFill>
           </a:ln>
         </p:spPr>
@@ -9447,7 +9799,7 @@
             </a:avLst>
           </a:prstGeom>
           <a:solidFill>
-            <a:srgbClr val="0E3B20"/>
+            <a:srgbClr val="005C38"/>
           </a:solidFill>
           <a:ln>
             <a:noFill/>
@@ -9514,7 +9866,7 @@
             <a:r>
               <a:rPr sz="1200" b="0" i="0">
                 <a:solidFill>
-                  <a:srgbClr val="E3F2E8"/>
+                  <a:srgbClr val="E0F3E9"/>
                 </a:solidFill>
                 <a:latin typeface="Calibri"/>
               </a:rPr>
@@ -9539,7 +9891,7 @@
           </a:prstGeom>
           <a:ln w="15875">
             <a:solidFill>
-              <a:srgbClr val="E3F2E8"/>
+              <a:srgbClr val="E0F3E9"/>
             </a:solidFill>
           </a:ln>
         </p:spPr>
@@ -9584,7 +9936,7 @@
             <a:r>
               <a:rPr sz="1400" b="0" i="0">
                 <a:solidFill>
-                  <a:srgbClr val="E3F2E8"/>
+                  <a:srgbClr val="E0F3E9"/>
                 </a:solidFill>
                 <a:latin typeface="Calibri"/>
               </a:rPr>
@@ -9706,7 +10058,7 @@
             </a:avLst>
           </a:prstGeom>
           <a:solidFill>
-            <a:srgbClr val="E3F2E8"/>
+            <a:srgbClr val="E0F3E9"/>
           </a:solidFill>
           <a:ln w="12700">
             <a:solidFill>
@@ -9799,7 +10151,7 @@
             <a:avLst/>
           </a:prstGeom>
           <a:solidFill>
-            <a:srgbClr val="14532D"/>
+            <a:srgbClr val="007A4A"/>
           </a:solidFill>
           <a:ln>
             <a:noFill/>
@@ -9982,7 +10334,7 @@
             <a:avLst/>
           </a:prstGeom>
           <a:solidFill>
-            <a:srgbClr val="14532D"/>
+            <a:srgbClr val="007A4A"/>
           </a:solidFill>
           <a:ln>
             <a:noFill/>
@@ -10072,7 +10424,7 @@
             </a:avLst>
           </a:prstGeom>
           <a:solidFill>
-            <a:srgbClr val="E3F2E8"/>
+            <a:srgbClr val="E0F3E9"/>
           </a:solidFill>
           <a:ln w="12700">
             <a:solidFill>
@@ -10165,7 +10517,7 @@
             <a:avLst/>
           </a:prstGeom>
           <a:solidFill>
-            <a:srgbClr val="14532D"/>
+            <a:srgbClr val="007A4A"/>
           </a:solidFill>
           <a:ln>
             <a:noFill/>
@@ -10348,7 +10700,7 @@
             <a:avLst/>
           </a:prstGeom>
           <a:solidFill>
-            <a:srgbClr val="14532D"/>
+            <a:srgbClr val="007A4A"/>
           </a:solidFill>
           <a:ln>
             <a:noFill/>
@@ -10438,7 +10790,7 @@
             </a:avLst>
           </a:prstGeom>
           <a:solidFill>
-            <a:srgbClr val="E3F2E8"/>
+            <a:srgbClr val="E0F3E9"/>
           </a:solidFill>
           <a:ln w="12700">
             <a:solidFill>
@@ -10531,7 +10883,7 @@
             <a:avLst/>
           </a:prstGeom>
           <a:solidFill>
-            <a:srgbClr val="14532D"/>
+            <a:srgbClr val="007A4A"/>
           </a:solidFill>
           <a:ln>
             <a:noFill/>
@@ -10790,7 +11142,7 @@
             <a:r>
               <a:rPr sz="2000" b="1" i="0">
                 <a:solidFill>
-                  <a:srgbClr val="14532D"/>
+                  <a:srgbClr val="007A4A"/>
                 </a:solidFill>
                 <a:latin typeface="Cambria"/>
               </a:rPr>
@@ -10889,7 +11241,7 @@
             <a:r>
               <a:rPr sz="2000" b="1" i="0">
                 <a:solidFill>
-                  <a:srgbClr val="14532D"/>
+                  <a:srgbClr val="007A4A"/>
                 </a:solidFill>
                 <a:latin typeface="Cambria"/>
               </a:rPr>
@@ -10928,7 +11280,7 @@
                 </a:solidFill>
                 <a:latin typeface="Calibri"/>
               </a:rPr>
-              <a:t>Chaque résultat est lu à voix haute ; chaque fiche a son audio en fon, yoruba, bariba ou dendi, enregistré par le conseiller.</a:t>
+              <a:t>Chaque résultat est lu à voix haute. Les fiches parlent fon et yoruba grâce à 229langues, voix de synthèse signalée comme telle, jusqu’à l’enregistrement du conseiller.</a:t>
             </a:r>
           </a:p>
         </p:txBody>
@@ -10988,7 +11340,7 @@
             <a:r>
               <a:rPr sz="2000" b="1" i="0">
                 <a:solidFill>
-                  <a:srgbClr val="14532D"/>
+                  <a:srgbClr val="007A4A"/>
                 </a:solidFill>
                 <a:latin typeface="Cambria"/>
               </a:rPr>
@@ -11143,7 +11495,7 @@
             <a:avLst/>
           </a:prstGeom>
           <a:solidFill>
-            <a:srgbClr val="14532D"/>
+            <a:srgbClr val="007A4A"/>
           </a:solidFill>
           <a:ln>
             <a:noFill/>
@@ -11266,7 +11618,7 @@
             <a:avLst/>
           </a:prstGeom>
           <a:solidFill>
-            <a:srgbClr val="14532D"/>
+            <a:srgbClr val="007A4A"/>
           </a:solidFill>
           <a:ln>
             <a:noFill/>
@@ -11389,7 +11741,7 @@
             <a:avLst/>
           </a:prstGeom>
           <a:solidFill>
-            <a:srgbClr val="14532D"/>
+            <a:srgbClr val="007A4A"/>
           </a:solidFill>
           <a:ln>
             <a:noFill/>
@@ -11512,7 +11864,7 @@
             <a:avLst/>
           </a:prstGeom>
           <a:solidFill>
-            <a:srgbClr val="14532D"/>
+            <a:srgbClr val="007A4A"/>
           </a:solidFill>
           <a:ln>
             <a:noFill/>
@@ -11635,7 +11987,7 @@
             <a:avLst/>
           </a:prstGeom>
           <a:solidFill>
-            <a:srgbClr val="14532D"/>
+            <a:srgbClr val="007A4A"/>
           </a:solidFill>
           <a:ln>
             <a:noFill/>
@@ -11758,7 +12110,7 @@
             <a:avLst/>
           </a:prstGeom>
           <a:solidFill>
-            <a:srgbClr val="14532D"/>
+            <a:srgbClr val="007A4A"/>
           </a:solidFill>
           <a:ln>
             <a:noFill/>
@@ -12052,7 +12404,7 @@
             </a:avLst>
           </a:prstGeom>
           <a:solidFill>
-            <a:srgbClr val="E3F2E8"/>
+            <a:srgbClr val="E0F3E9"/>
           </a:solidFill>
           <a:ln>
             <a:noFill/>
@@ -12096,7 +12448,7 @@
             <a:avLst/>
           </a:prstGeom>
           <a:solidFill>
-            <a:srgbClr val="14532D"/>
+            <a:srgbClr val="007A4A"/>
           </a:solidFill>
           <a:ln>
             <a:noFill/>
@@ -12221,7 +12573,7 @@
             </a:avLst>
           </a:prstGeom>
           <a:solidFill>
-            <a:srgbClr val="E3F2E8"/>
+            <a:srgbClr val="E0F3E9"/>
           </a:solidFill>
           <a:ln>
             <a:noFill/>
@@ -12390,7 +12742,7 @@
             </a:avLst>
           </a:prstGeom>
           <a:solidFill>
-            <a:srgbClr val="E3F2E8"/>
+            <a:srgbClr val="E0F3E9"/>
           </a:solidFill>
           <a:ln>
             <a:noFill/>
@@ -12434,7 +12786,7 @@
             <a:avLst/>
           </a:prstGeom>
           <a:solidFill>
-            <a:srgbClr val="14532D"/>
+            <a:srgbClr val="007A4A"/>
           </a:solidFill>
           <a:ln>
             <a:noFill/>
@@ -12559,7 +12911,7 @@
             </a:avLst>
           </a:prstGeom>
           <a:solidFill>
-            <a:srgbClr val="E3F2E8"/>
+            <a:srgbClr val="E0F3E9"/>
           </a:solidFill>
           <a:ln>
             <a:noFill/>

</xml_diff>

<commit_message>
docs: close KI-007, KI-009, KI-019 and KI-020 and refresh the figures
Report, demo script, presentation and the pentest follow-up match the
code; KI-024 records the hosting region.
</commit_message>
<xml_diff>
--- a/docs/presentation/AlerteAgri-presentation.pptx
+++ b/docs/presentation/AlerteAgri-presentation.pptx
@@ -5710,7 +5710,7 @@
                 </a:solidFill>
                 <a:latin typeface="Cambria"/>
               </a:rPr>
-              <a:t>313</a:t>
+              <a:t>318</a:t>
             </a:r>
           </a:p>
         </p:txBody>
@@ -5780,7 +5780,7 @@
                 </a:solidFill>
                 <a:latin typeface="Calibri"/>
               </a:rPr>
-              <a:t>82 métier, 59 API sur PostgreSQL, 172 dans le navigateur</a:t>
+              <a:t>86 métier, 60 API sur PostgreSQL, 172 dans le navigateur</a:t>
             </a:r>
           </a:p>
         </p:txBody>

</xml_diff>

<commit_message>
docs: state that only human voices are played and close KI-022 and KI-023
</commit_message>
<xml_diff>
--- a/docs/presentation/AlerteAgri-presentation.pptx
+++ b/docs/presentation/AlerteAgri-presentation.pptx
@@ -5710,7 +5710,7 @@
                 </a:solidFill>
                 <a:latin typeface="Cambria"/>
               </a:rPr>
-              <a:t>318</a:t>
+              <a:t>320</a:t>
             </a:r>
           </a:p>
         </p:txBody>
@@ -5780,7 +5780,7 @@
                 </a:solidFill>
                 <a:latin typeface="Calibri"/>
               </a:rPr>
-              <a:t>86 métier, 60 API sur PostgreSQL, 172 dans le navigateur</a:t>
+              <a:t>87 métier, 61 API sur PostgreSQL, 172 dans le navigateur</a:t>
             </a:r>
           </a:p>
         </p:txBody>
@@ -11245,7 +11245,7 @@
                 </a:solidFill>
                 <a:latin typeface="Cambria"/>
               </a:rPr>
-              <a:t>Voix et SMS</a:t>
+              <a:t>Pictos et voix humaine</a:t>
             </a:r>
           </a:p>
         </p:txBody>
@@ -11280,7 +11280,7 @@
                 </a:solidFill>
                 <a:latin typeface="Calibri"/>
               </a:rPr>
-              <a:t>Chaque résultat est lu à voix haute. Les fiches parlent fon et yoruba grâce à 229langues, voix de synthèse signalée comme telle, jusqu’à l’enregistrement du conseiller.</a:t>
+              <a:t>Chaque culture et chaque symptôme a son image. Les fiches se lisent en pictogrammes ; en langue locale, c’est la voix du conseiller, enregistrée depuis son téléphone.</a:t>
             </a:r>
           </a:p>
         </p:txBody>

</xml_diff>

<commit_message>
docs: record the real-use analysis, its fixes and what remains open
</commit_message>
<xml_diff>
--- a/docs/presentation/AlerteAgri-presentation.pptx
+++ b/docs/presentation/AlerteAgri-presentation.pptx
@@ -5710,7 +5710,7 @@
                 </a:solidFill>
                 <a:latin typeface="Cambria"/>
               </a:rPr>
-              <a:t>320</a:t>
+              <a:t>342</a:t>
             </a:r>
           </a:p>
         </p:txBody>
@@ -5780,7 +5780,7 @@
                 </a:solidFill>
                 <a:latin typeface="Calibri"/>
               </a:rPr>
-              <a:t>87 métier, 61 API sur PostgreSQL, 172 dans le navigateur</a:t>
+              <a:t>91 métier, 65 API sur PostgreSQL, 186 dans le navigateur</a:t>
             </a:r>
           </a:p>
         </p:txBody>

</xml_diff>